<commit_message>
Explain signal phase on the week 7 example slide and add the speaking script.
Co-authored-by: Cursor <cursoragent@cursor.com>
</commit_message>
<xml_diff>
--- a/7주차_주간보고_수정.pptx
+++ b/7주차_주간보고_수정.pptx
@@ -8697,8 +8697,8 @@
         </p:nvSpPr>
         <p:spPr>
           <a:xfrm>
-            <a:off x="502920" y="1298448"/>
-            <a:ext cx="4709160" cy="1170432"/>
+            <a:off x="502920" y="2097024"/>
+            <a:ext cx="4709160" cy="1005840"/>
           </a:xfrm>
           <a:prstGeom prst="roundRect">
             <a:avLst>
@@ -8743,8 +8743,8 @@
         </p:nvSpPr>
         <p:spPr>
           <a:xfrm>
-            <a:off x="713232" y="1389888"/>
-            <a:ext cx="4297680" cy="292608"/>
+            <a:off x="713232" y="2161032"/>
+            <a:ext cx="4297680" cy="237744"/>
           </a:xfrm>
           <a:prstGeom prst="rect">
             <a:avLst/>
@@ -8785,28 +8785,31 @@
         </p:nvSpPr>
         <p:spPr>
           <a:xfrm>
-            <a:off x="713232" y="1682496"/>
-            <a:ext cx="4297680" cy="713232"/>
-          </a:xfrm>
-          <a:prstGeom prst="rect">
-            <a:avLst/>
-          </a:prstGeom>
-          <a:noFill/>
-        </p:spPr>
-        <p:txBody>
-          <a:bodyPr wrap="square" lIns="0" tIns="0" rIns="0" bIns="0"/>
-          <a:lstStyle/>
-          <a:p>
-            <a:pPr algn="l">
-              <a:spcBef>
-                <a:spcPts val="0"/>
-              </a:spcBef>
-              <a:spcAft>
-                <a:spcPts val="0"/>
-              </a:spcAft>
-            </a:pPr>
-            <a:r>
-              <a:rPr sz="1400" b="0" i="0">
+            <a:off x="713232" y="2398776"/>
+            <a:ext cx="4297680" cy="640080"/>
+          </a:xfrm>
+          <a:prstGeom prst="rect">
+            <a:avLst/>
+          </a:prstGeom>
+          <a:noFill/>
+        </p:spPr>
+        <p:txBody>
+          <a:bodyPr wrap="square" lIns="0" tIns="0" rIns="0" bIns="0"/>
+          <a:lstStyle/>
+          <a:p>
+            <a:pPr algn="l">
+              <a:spcBef>
+                <a:spcPts val="0"/>
+              </a:spcBef>
+              <a:lnSpc>
+                <a:spcPts val="1600"/>
+              </a:lnSpc>
+              <a:spcAft>
+                <a:spcPts val="0"/>
+              </a:spcAft>
+            </a:pPr>
+            <a:r>
+              <a:rPr sz="1300" b="0" i="0">
                 <a:solidFill>
                   <a:srgbClr val="EEF3FB"/>
                 </a:solidFill>
@@ -8822,12 +8825,15 @@
               <a:spcBef>
                 <a:spcPts val="0"/>
               </a:spcBef>
-              <a:spcAft>
-                <a:spcPts val="0"/>
-              </a:spcAft>
-            </a:pPr>
-            <a:r>
-              <a:rPr sz="1400" b="0" i="0">
+              <a:lnSpc>
+                <a:spcPts val="1600"/>
+              </a:lnSpc>
+              <a:spcAft>
+                <a:spcPts val="0"/>
+              </a:spcAft>
+            </a:pPr>
+            <a:r>
+              <a:rPr sz="1300" b="0" i="0">
                 <a:solidFill>
                   <a:srgbClr val="EEF3FB"/>
                 </a:solidFill>
@@ -8843,12 +8849,15 @@
               <a:spcBef>
                 <a:spcPts val="0"/>
               </a:spcBef>
-              <a:spcAft>
-                <a:spcPts val="0"/>
-              </a:spcAft>
-            </a:pPr>
-            <a:r>
-              <a:rPr sz="1400" b="0" i="0">
+              <a:lnSpc>
+                <a:spcPts val="1600"/>
+              </a:lnSpc>
+              <a:spcAft>
+                <a:spcPts val="0"/>
+              </a:spcAft>
+            </a:pPr>
+            <a:r>
+              <a:rPr sz="1300" b="0" i="0">
                 <a:solidFill>
                   <a:srgbClr val="EEF3FB"/>
                 </a:solidFill>
@@ -8869,8 +8878,8 @@
         </p:nvSpPr>
         <p:spPr>
           <a:xfrm>
-            <a:off x="502920" y="2542032"/>
-            <a:ext cx="4709160" cy="1170432"/>
+            <a:off x="502920" y="3153156"/>
+            <a:ext cx="4709160" cy="1005840"/>
           </a:xfrm>
           <a:prstGeom prst="roundRect">
             <a:avLst>
@@ -8915,8 +8924,8 @@
         </p:nvSpPr>
         <p:spPr>
           <a:xfrm>
-            <a:off x="713232" y="2633472"/>
-            <a:ext cx="4297680" cy="292608"/>
+            <a:off x="713232" y="3217164"/>
+            <a:ext cx="4297680" cy="237744"/>
           </a:xfrm>
           <a:prstGeom prst="rect">
             <a:avLst/>
@@ -8957,28 +8966,31 @@
         </p:nvSpPr>
         <p:spPr>
           <a:xfrm>
-            <a:off x="713232" y="2926080"/>
-            <a:ext cx="4297680" cy="713232"/>
-          </a:xfrm>
-          <a:prstGeom prst="rect">
-            <a:avLst/>
-          </a:prstGeom>
-          <a:noFill/>
-        </p:spPr>
-        <p:txBody>
-          <a:bodyPr wrap="square" lIns="0" tIns="0" rIns="0" bIns="0"/>
-          <a:lstStyle/>
-          <a:p>
-            <a:pPr algn="l">
-              <a:spcBef>
-                <a:spcPts val="0"/>
-              </a:spcBef>
-              <a:spcAft>
-                <a:spcPts val="0"/>
-              </a:spcAft>
-            </a:pPr>
-            <a:r>
-              <a:rPr sz="1400" b="0" i="0">
+            <a:off x="713232" y="3454908"/>
+            <a:ext cx="4297680" cy="640080"/>
+          </a:xfrm>
+          <a:prstGeom prst="rect">
+            <a:avLst/>
+          </a:prstGeom>
+          <a:noFill/>
+        </p:spPr>
+        <p:txBody>
+          <a:bodyPr wrap="square" lIns="0" tIns="0" rIns="0" bIns="0"/>
+          <a:lstStyle/>
+          <a:p>
+            <a:pPr algn="l">
+              <a:spcBef>
+                <a:spcPts val="0"/>
+              </a:spcBef>
+              <a:lnSpc>
+                <a:spcPts val="1600"/>
+              </a:lnSpc>
+              <a:spcAft>
+                <a:spcPts val="0"/>
+              </a:spcAft>
+            </a:pPr>
+            <a:r>
+              <a:rPr sz="1300" b="0" i="0">
                 <a:solidFill>
                   <a:srgbClr val="EEF3FB"/>
                 </a:solidFill>
@@ -8994,12 +9006,15 @@
               <a:spcBef>
                 <a:spcPts val="0"/>
               </a:spcBef>
-              <a:spcAft>
-                <a:spcPts val="0"/>
-              </a:spcAft>
-            </a:pPr>
-            <a:r>
-              <a:rPr sz="1400" b="0" i="0">
+              <a:lnSpc>
+                <a:spcPts val="1600"/>
+              </a:lnSpc>
+              <a:spcAft>
+                <a:spcPts val="0"/>
+              </a:spcAft>
+            </a:pPr>
+            <a:r>
+              <a:rPr sz="1300" b="0" i="0">
                 <a:solidFill>
                   <a:srgbClr val="EEF3FB"/>
                 </a:solidFill>
@@ -9015,12 +9030,15 @@
               <a:spcBef>
                 <a:spcPts val="0"/>
               </a:spcBef>
-              <a:spcAft>
-                <a:spcPts val="0"/>
-              </a:spcAft>
-            </a:pPr>
-            <a:r>
-              <a:rPr sz="1400" b="0" i="0">
+              <a:lnSpc>
+                <a:spcPts val="1600"/>
+              </a:lnSpc>
+              <a:spcAft>
+                <a:spcPts val="0"/>
+              </a:spcAft>
+            </a:pPr>
+            <a:r>
+              <a:rPr sz="1300" b="0" i="0">
                 <a:solidFill>
                   <a:srgbClr val="EEF3FB"/>
                 </a:solidFill>
@@ -9041,8 +9059,8 @@
         </p:nvSpPr>
         <p:spPr>
           <a:xfrm>
-            <a:off x="502920" y="3785616"/>
-            <a:ext cx="4709160" cy="1170432"/>
+            <a:off x="502920" y="4209288"/>
+            <a:ext cx="4709160" cy="1005840"/>
           </a:xfrm>
           <a:prstGeom prst="roundRect">
             <a:avLst>
@@ -9087,8 +9105,8 @@
         </p:nvSpPr>
         <p:spPr>
           <a:xfrm>
-            <a:off x="713232" y="3877056"/>
-            <a:ext cx="4297680" cy="292608"/>
+            <a:off x="713232" y="4273296"/>
+            <a:ext cx="4297680" cy="237744"/>
           </a:xfrm>
           <a:prstGeom prst="rect">
             <a:avLst/>
@@ -9129,28 +9147,31 @@
         </p:nvSpPr>
         <p:spPr>
           <a:xfrm>
-            <a:off x="713232" y="4169664"/>
-            <a:ext cx="4297680" cy="713232"/>
-          </a:xfrm>
-          <a:prstGeom prst="rect">
-            <a:avLst/>
-          </a:prstGeom>
-          <a:noFill/>
-        </p:spPr>
-        <p:txBody>
-          <a:bodyPr wrap="square" lIns="0" tIns="0" rIns="0" bIns="0"/>
-          <a:lstStyle/>
-          <a:p>
-            <a:pPr algn="l">
-              <a:spcBef>
-                <a:spcPts val="0"/>
-              </a:spcBef>
-              <a:spcAft>
-                <a:spcPts val="0"/>
-              </a:spcAft>
-            </a:pPr>
-            <a:r>
-              <a:rPr sz="1400" b="0" i="0">
+            <a:off x="713232" y="4511040"/>
+            <a:ext cx="4297680" cy="640080"/>
+          </a:xfrm>
+          <a:prstGeom prst="rect">
+            <a:avLst/>
+          </a:prstGeom>
+          <a:noFill/>
+        </p:spPr>
+        <p:txBody>
+          <a:bodyPr wrap="square" lIns="0" tIns="0" rIns="0" bIns="0"/>
+          <a:lstStyle/>
+          <a:p>
+            <a:pPr algn="l">
+              <a:spcBef>
+                <a:spcPts val="0"/>
+              </a:spcBef>
+              <a:lnSpc>
+                <a:spcPts val="1600"/>
+              </a:lnSpc>
+              <a:spcAft>
+                <a:spcPts val="0"/>
+              </a:spcAft>
+            </a:pPr>
+            <a:r>
+              <a:rPr sz="1300" b="0" i="0">
                 <a:solidFill>
                   <a:srgbClr val="EEF3FB"/>
                 </a:solidFill>
@@ -9166,12 +9187,15 @@
               <a:spcBef>
                 <a:spcPts val="0"/>
               </a:spcBef>
-              <a:spcAft>
-                <a:spcPts val="0"/>
-              </a:spcAft>
-            </a:pPr>
-            <a:r>
-              <a:rPr sz="1400" b="0" i="0">
+              <a:lnSpc>
+                <a:spcPts val="1600"/>
+              </a:lnSpc>
+              <a:spcAft>
+                <a:spcPts val="0"/>
+              </a:spcAft>
+            </a:pPr>
+            <a:r>
+              <a:rPr sz="1300" b="0" i="0">
                 <a:solidFill>
                   <a:srgbClr val="EEF3FB"/>
                 </a:solidFill>
@@ -9192,8 +9216,8 @@
         </p:nvSpPr>
         <p:spPr>
           <a:xfrm>
-            <a:off x="502920" y="5029200"/>
-            <a:ext cx="4709160" cy="1170432"/>
+            <a:off x="502920" y="5265420"/>
+            <a:ext cx="4709160" cy="1005840"/>
           </a:xfrm>
           <a:prstGeom prst="roundRect">
             <a:avLst>
@@ -9238,8 +9262,8 @@
         </p:nvSpPr>
         <p:spPr>
           <a:xfrm>
-            <a:off x="713232" y="5120640"/>
-            <a:ext cx="4297680" cy="292608"/>
+            <a:off x="713232" y="5329428"/>
+            <a:ext cx="4297680" cy="237744"/>
           </a:xfrm>
           <a:prstGeom prst="rect">
             <a:avLst/>
@@ -9280,28 +9304,31 @@
         </p:nvSpPr>
         <p:spPr>
           <a:xfrm>
-            <a:off x="713232" y="5413248"/>
-            <a:ext cx="4297680" cy="713232"/>
-          </a:xfrm>
-          <a:prstGeom prst="rect">
-            <a:avLst/>
-          </a:prstGeom>
-          <a:noFill/>
-        </p:spPr>
-        <p:txBody>
-          <a:bodyPr wrap="square" lIns="0" tIns="0" rIns="0" bIns="0"/>
-          <a:lstStyle/>
-          <a:p>
-            <a:pPr algn="l">
-              <a:spcBef>
-                <a:spcPts val="0"/>
-              </a:spcBef>
-              <a:spcAft>
-                <a:spcPts val="0"/>
-              </a:spcAft>
-            </a:pPr>
-            <a:r>
-              <a:rPr sz="1400" b="0" i="0">
+            <a:off x="713232" y="5567172"/>
+            <a:ext cx="4297680" cy="640080"/>
+          </a:xfrm>
+          <a:prstGeom prst="rect">
+            <a:avLst/>
+          </a:prstGeom>
+          <a:noFill/>
+        </p:spPr>
+        <p:txBody>
+          <a:bodyPr wrap="square" lIns="0" tIns="0" rIns="0" bIns="0"/>
+          <a:lstStyle/>
+          <a:p>
+            <a:pPr algn="l">
+              <a:spcBef>
+                <a:spcPts val="0"/>
+              </a:spcBef>
+              <a:lnSpc>
+                <a:spcPts val="1600"/>
+              </a:lnSpc>
+              <a:spcAft>
+                <a:spcPts val="0"/>
+              </a:spcAft>
+            </a:pPr>
+            <a:r>
+              <a:rPr sz="1300" b="0" i="0">
                 <a:solidFill>
                   <a:srgbClr val="EEF3FB"/>
                 </a:solidFill>
@@ -9317,12 +9344,15 @@
               <a:spcBef>
                 <a:spcPts val="0"/>
               </a:spcBef>
-              <a:spcAft>
-                <a:spcPts val="0"/>
-              </a:spcAft>
-            </a:pPr>
-            <a:r>
-              <a:rPr sz="1400" b="0" i="0">
+              <a:lnSpc>
+                <a:spcPts val="1600"/>
+              </a:lnSpc>
+              <a:spcAft>
+                <a:spcPts val="0"/>
+              </a:spcAft>
+            </a:pPr>
+            <a:r>
+              <a:rPr sz="1300" b="0" i="0">
                 <a:solidFill>
                   <a:srgbClr val="EEF3FB"/>
                 </a:solidFill>
@@ -9351,14 +9381,249 @@
         </p:blipFill>
         <p:spPr>
           <a:xfrm>
-            <a:off x="5486400" y="1298448"/>
-            <a:ext cx="6172200" cy="4892040"/>
+            <a:off x="5486400" y="2097024"/>
+            <a:ext cx="6172200" cy="4174236"/>
           </a:xfrm>
           <a:prstGeom prst="rect">
             <a:avLst/>
           </a:prstGeom>
         </p:spPr>
       </p:pic>
+      <p:sp>
+        <p:nvSpPr>
+          <p:cNvPr id="20" name="현시 설명"/>
+          <p:cNvSpPr/>
+          <p:nvPr/>
+        </p:nvSpPr>
+        <p:spPr>
+          <a:xfrm>
+            <a:off x="502920" y="1170432"/>
+            <a:ext cx="11155680" cy="822960"/>
+          </a:xfrm>
+          <a:prstGeom prst="roundRect">
+            <a:avLst>
+              <a:gd name="adj" fmla="val 8000"/>
+            </a:avLst>
+          </a:prstGeom>
+          <a:solidFill>
+            <a:srgbClr val="10182A"/>
+          </a:solidFill>
+          <a:ln>
+            <a:noFill/>
+          </a:ln>
+        </p:spPr>
+        <p:txBody>
+          <a:bodyPr rtlCol="0" anchor="ctr"/>
+          <a:lstStyle/>
+          <a:p>
+            <a:pPr algn="ctr"/>
+          </a:p>
+        </p:txBody>
+      </p:sp>
+      <p:sp>
+        <p:nvSpPr>
+          <p:cNvPr id="21" name="TextBox 20"/>
+          <p:cNvSpPr txBox="1"/>
+          <p:nvPr/>
+        </p:nvSpPr>
+        <p:spPr>
+          <a:xfrm>
+            <a:off x="713232" y="1225296"/>
+            <a:ext cx="5230368" cy="219456"/>
+          </a:xfrm>
+          <a:prstGeom prst="rect">
+            <a:avLst/>
+          </a:prstGeom>
+          <a:noFill/>
+        </p:spPr>
+        <p:txBody>
+          <a:bodyPr wrap="square" lIns="0" rIns="0" tIns="0" bIns="0"/>
+          <a:lstStyle/>
+          <a:p>
+            <a:pPr>
+              <a:lnSpc>
+                <a:spcPts val="1500"/>
+              </a:lnSpc>
+              <a:spcBef>
+                <a:spcPts val="0"/>
+              </a:spcBef>
+              <a:spcAft>
+                <a:spcPts val="0"/>
+              </a:spcAft>
+            </a:pPr>
+            <a:r>
+              <a:rPr sz="1300" b="1">
+                <a:solidFill>
+                  <a:srgbClr val="5B8DEF"/>
+                </a:solidFill>
+                <a:latin typeface="Malgun Gothic"/>
+                <a:ea typeface="Malgun Gothic"/>
+                <a:cs typeface="Malgun Gothic"/>
+              </a:rPr>
+              <a:t>현시</a:t>
+            </a:r>
+          </a:p>
+        </p:txBody>
+      </p:sp>
+      <p:sp>
+        <p:nvSpPr>
+          <p:cNvPr id="22" name="TextBox 21"/>
+          <p:cNvSpPr txBox="1"/>
+          <p:nvPr/>
+        </p:nvSpPr>
+        <p:spPr>
+          <a:xfrm>
+            <a:off x="713232" y="1444752"/>
+            <a:ext cx="5230368" cy="502920"/>
+          </a:xfrm>
+          <a:prstGeom prst="rect">
+            <a:avLst/>
+          </a:prstGeom>
+          <a:noFill/>
+        </p:spPr>
+        <p:txBody>
+          <a:bodyPr wrap="square" lIns="0" rIns="0" tIns="0" bIns="0"/>
+          <a:lstStyle/>
+          <a:p>
+            <a:pPr>
+              <a:lnSpc>
+                <a:spcPts val="1800"/>
+              </a:lnSpc>
+              <a:spcBef>
+                <a:spcPts val="0"/>
+              </a:spcBef>
+              <a:spcAft>
+                <a:spcPts val="0"/>
+              </a:spcAft>
+            </a:pPr>
+            <a:r>
+              <a:rPr sz="1400" b="0">
+                <a:solidFill>
+                  <a:srgbClr val="EEF3FB"/>
+                </a:solidFill>
+                <a:latin typeface="Malgun Gothic"/>
+                <a:ea typeface="Malgun Gothic"/>
+                <a:cs typeface="Malgun Gothic"/>
+              </a:rPr>
+              <a:t>같은 시각에 통행권이 주어지는 신호의 한 단계입니다.</a:t>
+            </a:r>
+          </a:p>
+          <a:p>
+            <a:pPr>
+              <a:lnSpc>
+                <a:spcPts val="1800"/>
+              </a:lnSpc>
+              <a:spcBef>
+                <a:spcPts val="0"/>
+              </a:spcBef>
+              <a:spcAft>
+                <a:spcPts val="0"/>
+              </a:spcAft>
+            </a:pPr>
+            <a:r>
+              <a:rPr sz="1400" b="0">
+                <a:solidFill>
+                  <a:srgbClr val="EEF3FB"/>
+                </a:solidFill>
+                <a:latin typeface="Malgun Gothic"/>
+                <a:ea typeface="Malgun Gothic"/>
+                <a:cs typeface="Malgun Gothic"/>
+              </a:rPr>
+              <a:t>북쪽 직진과 동쪽 직진은 서로 다른 현시입니다.</a:t>
+            </a:r>
+          </a:p>
+        </p:txBody>
+      </p:sp>
+      <p:sp>
+        <p:nvSpPr>
+          <p:cNvPr id="23" name="TextBox 22"/>
+          <p:cNvSpPr txBox="1"/>
+          <p:nvPr/>
+        </p:nvSpPr>
+        <p:spPr>
+          <a:xfrm>
+            <a:off x="6217920" y="1225296"/>
+            <a:ext cx="5230368" cy="219456"/>
+          </a:xfrm>
+          <a:prstGeom prst="rect">
+            <a:avLst/>
+          </a:prstGeom>
+          <a:noFill/>
+        </p:spPr>
+        <p:txBody>
+          <a:bodyPr wrap="square" lIns="0" rIns="0" tIns="0" bIns="0"/>
+          <a:lstStyle/>
+          <a:p>
+            <a:pPr>
+              <a:lnSpc>
+                <a:spcPts val="1500"/>
+              </a:lnSpc>
+              <a:spcBef>
+                <a:spcPts val="0"/>
+              </a:spcBef>
+              <a:spcAft>
+                <a:spcPts val="0"/>
+              </a:spcAft>
+            </a:pPr>
+            <a:r>
+              <a:rPr sz="1300" b="1">
+                <a:solidFill>
+                  <a:srgbClr val="5B8DEF"/>
+                </a:solidFill>
+                <a:latin typeface="Malgun Gothic"/>
+                <a:ea typeface="Malgun Gothic"/>
+                <a:cs typeface="Malgun Gothic"/>
+              </a:rPr>
+              <a:t>현시 복귀</a:t>
+            </a:r>
+          </a:p>
+        </p:txBody>
+      </p:sp>
+      <p:sp>
+        <p:nvSpPr>
+          <p:cNvPr id="24" name="TextBox 23"/>
+          <p:cNvSpPr txBox="1"/>
+          <p:nvPr/>
+        </p:nvSpPr>
+        <p:spPr>
+          <a:xfrm>
+            <a:off x="6217920" y="1444752"/>
+            <a:ext cx="5230368" cy="502920"/>
+          </a:xfrm>
+          <a:prstGeom prst="rect">
+            <a:avLst/>
+          </a:prstGeom>
+          <a:noFill/>
+        </p:spPr>
+        <p:txBody>
+          <a:bodyPr wrap="square" lIns="0" rIns="0" tIns="0" bIns="0"/>
+          <a:lstStyle/>
+          <a:p>
+            <a:pPr>
+              <a:lnSpc>
+                <a:spcPts val="1800"/>
+              </a:lnSpc>
+              <a:spcBef>
+                <a:spcPts val="0"/>
+              </a:spcBef>
+              <a:spcAft>
+                <a:spcPts val="0"/>
+              </a:spcAft>
+            </a:pPr>
+            <a:r>
+              <a:rPr sz="1400" b="0">
+                <a:solidFill>
+                  <a:srgbClr val="EEF3FB"/>
+                </a:solidFill>
+                <a:latin typeface="Malgun Gothic"/>
+                <a:ea typeface="Malgun Gothic"/>
+                <a:cs typeface="Malgun Gothic"/>
+              </a:rPr>
+              <a:t>그 시각의 계획된 현시로 점등을 되돌리는 일입니다.</a:t>
+            </a:r>
+          </a:p>
+        </p:txBody>
+      </p:sp>
     </p:spTree>
   </p:cSld>
   <p:clrMapOvr>

</xml_diff>

<commit_message>
Publish the revised week 7 report so the deck and the report page match.
Co-authored-by: Cursor <cursoragent@cursor.com>
</commit_message>
<xml_diff>
--- a/7주차_주간보고_수정.pptx
+++ b/7주차_주간보고_수정.pptx
@@ -4400,7 +4400,7 @@
               </a:spcAft>
             </a:pPr>
             <a:r>
-              <a:rPr sz="1600" b="1" i="0">
+              <a:rPr sz="1600" b="1" i="0" dirty="0" err="1">
                 <a:solidFill>
                   <a:srgbClr val="EEF3FB"/>
                 </a:solidFill>
@@ -4408,8 +4408,38 @@
                 <a:ea typeface="Malgun Gothic"/>
                 <a:cs typeface="Malgun Gothic"/>
               </a:rPr>
-              <a:t>처리 두 갈래</a:t>
-            </a:r>
+              <a:t>처리</a:t>
+            </a:r>
+            <a:r>
+              <a:rPr sz="1600" b="1" i="0" dirty="0">
+                <a:solidFill>
+                  <a:srgbClr val="EEF3FB"/>
+                </a:solidFill>
+                <a:latin typeface="Malgun Gothic"/>
+                <a:ea typeface="Malgun Gothic"/>
+                <a:cs typeface="Malgun Gothic"/>
+              </a:rPr>
+              <a:t> </a:t>
+            </a:r>
+            <a:r>
+              <a:rPr lang="ko-KR" altLang="en-US" sz="1600" b="1" dirty="0">
+                <a:solidFill>
+                  <a:srgbClr val="EEF3FB"/>
+                </a:solidFill>
+                <a:latin typeface="Malgun Gothic"/>
+                <a:ea typeface="Malgun Gothic"/>
+                <a:cs typeface="Malgun Gothic"/>
+              </a:rPr>
+              <a:t>방법</a:t>
+            </a:r>
+            <a:endParaRPr sz="1600" b="1" i="0" dirty="0">
+              <a:solidFill>
+                <a:srgbClr val="EEF3FB"/>
+              </a:solidFill>
+              <a:latin typeface="Malgun Gothic"/>
+              <a:ea typeface="Malgun Gothic"/>
+              <a:cs typeface="Malgun Gothic"/>
+            </a:endParaRPr>
           </a:p>
         </p:txBody>
       </p:sp>
@@ -8801,9 +8831,6 @@
               <a:spcBef>
                 <a:spcPts val="0"/>
               </a:spcBef>
-              <a:lnSpc>
-                <a:spcPts val="1600"/>
-              </a:lnSpc>
               <a:spcAft>
                 <a:spcPts val="0"/>
               </a:spcAft>
@@ -8825,9 +8852,6 @@
               <a:spcBef>
                 <a:spcPts val="0"/>
               </a:spcBef>
-              <a:lnSpc>
-                <a:spcPts val="1600"/>
-              </a:lnSpc>
               <a:spcAft>
                 <a:spcPts val="0"/>
               </a:spcAft>
@@ -8849,9 +8873,6 @@
               <a:spcBef>
                 <a:spcPts val="0"/>
               </a:spcBef>
-              <a:lnSpc>
-                <a:spcPts val="1600"/>
-              </a:lnSpc>
               <a:spcAft>
                 <a:spcPts val="0"/>
               </a:spcAft>
@@ -8982,9 +9003,6 @@
               <a:spcBef>
                 <a:spcPts val="0"/>
               </a:spcBef>
-              <a:lnSpc>
-                <a:spcPts val="1600"/>
-              </a:lnSpc>
               <a:spcAft>
                 <a:spcPts val="0"/>
               </a:spcAft>
@@ -9006,9 +9024,6 @@
               <a:spcBef>
                 <a:spcPts val="0"/>
               </a:spcBef>
-              <a:lnSpc>
-                <a:spcPts val="1600"/>
-              </a:lnSpc>
               <a:spcAft>
                 <a:spcPts val="0"/>
               </a:spcAft>
@@ -9030,9 +9045,6 @@
               <a:spcBef>
                 <a:spcPts val="0"/>
               </a:spcBef>
-              <a:lnSpc>
-                <a:spcPts val="1600"/>
-              </a:lnSpc>
               <a:spcAft>
                 <a:spcPts val="0"/>
               </a:spcAft>
@@ -9163,9 +9175,6 @@
               <a:spcBef>
                 <a:spcPts val="0"/>
               </a:spcBef>
-              <a:lnSpc>
-                <a:spcPts val="1600"/>
-              </a:lnSpc>
               <a:spcAft>
                 <a:spcPts val="0"/>
               </a:spcAft>
@@ -9187,9 +9196,6 @@
               <a:spcBef>
                 <a:spcPts val="0"/>
               </a:spcBef>
-              <a:lnSpc>
-                <a:spcPts val="1600"/>
-              </a:lnSpc>
               <a:spcAft>
                 <a:spcPts val="0"/>
               </a:spcAft>
@@ -9320,9 +9326,6 @@
               <a:spcBef>
                 <a:spcPts val="0"/>
               </a:spcBef>
-              <a:lnSpc>
-                <a:spcPts val="1600"/>
-              </a:lnSpc>
               <a:spcAft>
                 <a:spcPts val="0"/>
               </a:spcAft>
@@ -9344,9 +9347,6 @@
               <a:spcBef>
                 <a:spcPts val="0"/>
               </a:spcBef>
-              <a:lnSpc>
-                <a:spcPts val="1600"/>
-              </a:lnSpc>
               <a:spcAft>
                 <a:spcPts val="0"/>
               </a:spcAft>
@@ -9417,6 +9417,7 @@
           <a:lstStyle/>
           <a:p>
             <a:pPr algn="ctr"/>
+            <a:endParaRPr/>
           </a:p>
         </p:txBody>
       </p:sp>
@@ -9437,7 +9438,7 @@
           <a:noFill/>
         </p:spPr>
         <p:txBody>
-          <a:bodyPr wrap="square" lIns="0" rIns="0" tIns="0" bIns="0"/>
+          <a:bodyPr wrap="square" lIns="0" tIns="0" rIns="0" bIns="0"/>
           <a:lstStyle/>
           <a:p>
             <a:pPr>
@@ -9482,7 +9483,7 @@
           <a:noFill/>
         </p:spPr>
         <p:txBody>
-          <a:bodyPr wrap="square" lIns="0" rIns="0" tIns="0" bIns="0"/>
+          <a:bodyPr wrap="square" lIns="0" tIns="0" rIns="0" bIns="0"/>
           <a:lstStyle/>
           <a:p>
             <a:pPr>
@@ -9551,7 +9552,7 @@
           <a:noFill/>
         </p:spPr>
         <p:txBody>
-          <a:bodyPr wrap="square" lIns="0" rIns="0" tIns="0" bIns="0"/>
+          <a:bodyPr wrap="square" lIns="0" tIns="0" rIns="0" bIns="0"/>
           <a:lstStyle/>
           <a:p>
             <a:pPr>
@@ -9596,7 +9597,7 @@
           <a:noFill/>
         </p:spPr>
         <p:txBody>
-          <a:bodyPr wrap="square" lIns="0" rIns="0" tIns="0" bIns="0"/>
+          <a:bodyPr wrap="square" lIns="0" tIns="0" rIns="0" bIns="0"/>
           <a:lstStyle/>
           <a:p>
             <a:pPr>

</xml_diff>